<commit_message>
Add goal-writing checklist to slide 4 speaker notes
Appended a 4-point checklist (what/by when/what level; action verbs
not feelings; specific not oversized; pick the one priority) to the
notes of the group-goal slide, so the facilitator can check written
goals against it. Slide bodies are unchanged.

Co-Authored-By: Claude Sonnet 5 <noreply@anthropic.com>
Claude-Session: https://claude.ai/code/session_01QBRDXNddJLki1ToZsFYVDX
</commit_message>
<xml_diff>
--- a/goal-setting-workshop/goal_setting_guide_8slides_pages_fixed.pptx
+++ b/goal-setting-workshop/goal_setting_guide_8slides_pages_fixed.pptx
@@ -1058,8 +1058,33 @@
           <a:lstStyle/>
           <a:p>
             <a:r>
-              <a:rPr dirty="0"/>
               <a:t>「グループ目標には、この3か月でみんなが目指すことを書きます。理由には、なぜその目標に取り組むのかを書きます。右の見本は書き方の参考です。グループで話し合って決めた内容を、同じようにわかりやすい言葉で書いてください。」（約20秒）</a:t>
+            </a:r>
+          </a:p>
+          <a:p/>
+          <a:p>
+            <a:r>
+              <a:t>【参考：目標の作り方チェック】</a:t>
+            </a:r>
+          </a:p>
+          <a:p>
+            <a:r>
+              <a:t>①「何を」「いつまでに」「どのレベル」まで入っているか</a:t>
+            </a:r>
+          </a:p>
+          <a:p>
+            <a:r>
+              <a:t>②「思う・考える」ではなく「書く・する・動く」など行動用語で書けているか</a:t>
+            </a:r>
+          </a:p>
+          <a:p>
+            <a:r>
+              <a:t>③大きすぎず具体的か（例：「レベルアップを図る」はNG、何を・どこまでかを書く）</a:t>
+            </a:r>
+          </a:p>
+          <a:p>
+            <a:r>
+              <a:t>④候補が複数あれば、一番大事な1つに絞る</a:t>
             </a:r>
           </a:p>
         </p:txBody>

</xml_diff>